<commit_message>
S01+S02 v3: sin early access, foco en que resuelve + sitio
</commit_message>
<xml_diff>
--- a/Domingo-14/S01_Domingo-14_2_Post_Nueva-forma-de-resolver_1x1.pptx
+++ b/Domingo-14/S01_Domingo-14_2_Post_Nueva-forma-de-resolver_1x1.pptx
@@ -3231,7 +3231,7 @@
         <p:spPr>
           <a:xfrm>
             <a:off x="777240" y="777240"/>
-            <a:ext cx="1892808" cy="373380"/>
+            <a:ext cx="2395728" cy="373380"/>
           </a:xfrm>
           <a:prstGeom prst="roundRect">
             <a:avLst>
@@ -3272,7 +3272,7 @@
                 </a:solidFill>
                 <a:latin typeface="Inter"/>
               </a:rPr>
-              <a:t>EARLY ACCESS</a:t>
+              <a:t>NOTALY VENEZUELA</a:t>
             </a:r>
           </a:p>
         </p:txBody>
@@ -3285,7 +3285,7 @@
         </p:nvSpPr>
         <p:spPr>
           <a:xfrm>
-            <a:off x="777240" y="1843786"/>
+            <a:off x="777240" y="2002536"/>
             <a:ext cx="1371600" cy="146304"/>
           </a:xfrm>
           <a:prstGeom prst="rect">
@@ -3329,8 +3329,8 @@
         </p:nvSpPr>
         <p:spPr>
           <a:xfrm>
-            <a:off x="777240" y="2300986"/>
-            <a:ext cx="6675120" cy="2896108"/>
+            <a:off x="777240" y="2459736"/>
+            <a:ext cx="6675120" cy="2578608"/>
           </a:xfrm>
           <a:prstGeom prst="rect">
             <a:avLst/>
@@ -3349,22 +3349,13 @@
               </a:lnSpc>
             </a:pPr>
             <a:r>
-              <a:rPr sz="4100" b="1">
-                <a:solidFill>
-                  <a:srgbClr val="7C3AED"/>
-                </a:solidFill>
-                <a:latin typeface="Inter"/>
-              </a:rPr>
-              <a:t>Ya disponible.</a:t>
-            </a:r>
-            <a:r>
-              <a:rPr sz="4100" b="1">
+              <a:rPr sz="4800" b="1">
                 <a:solidFill>
                   <a:srgbClr val="FFFFFF"/>
                 </a:solidFill>
                 <a:latin typeface="Inter"/>
               </a:rPr>
-              <a:t> Tu asesoría legal, 100% en línea.</a:t>
+              <a:t>Tu asesoría legal, 100% en línea.</a:t>
             </a:r>
           </a:p>
         </p:txBody>
@@ -3377,7 +3368,7 @@
         </p:nvSpPr>
         <p:spPr>
           <a:xfrm>
-            <a:off x="777240" y="5051552"/>
+            <a:off x="777240" y="5038344"/>
             <a:ext cx="6675120" cy="1943608"/>
           </a:xfrm>
           <a:prstGeom prst="rect">

</xml_diff>